<commit_message>
Verify omega rescaling, add demo/slide Breaker checks, CDN-failure fallback, deck fixes
Co-Authored-By: Claude Opus 5 (1M context) <noreply@anthropic.com>
</commit_message>
<xml_diff>
--- a/slides/qho-demo.pptx
+++ b/slides/qho-demo.pptx
@@ -8320,7 +8320,7 @@
                 </a:solidFill>
                 <a:latin typeface="Inter"/>
               </a:rPr>
-              <a:t>Tunnelling tails</a:t>
+              <a:t>Beyond the turning points</a:t>
             </a:r>
           </a:p>
         </p:txBody>
@@ -8359,7 +8359,7 @@
                 </a:solidFill>
                 <a:latin typeface="Inter"/>
               </a:rPr>
-              <a:t>ψ extends past the classical turning points where E = V(x), marked by the ends of each level line.</a:t>
+              <a:t>ψ leaks into the classically forbidden region where V(x) &gt; E. Each level line ends at a turning point.</a:t>
             </a:r>
           </a:p>
         </p:txBody>
@@ -9263,7 +9263,7 @@
                 </a:solidFill>
                 <a:latin typeface="Inter"/>
               </a:rPr>
-              <a:t>13 pytest checks</a:t>
+              <a:t>18 pytest checks</a:t>
             </a:r>
           </a:p>
         </p:txBody>
@@ -9458,6 +9458,25 @@
                 <a:latin typeface="Inter"/>
               </a:rPr>
               <a:t>O(h²) convergence</a:t>
+            </a:r>
+          </a:p>
+          <a:p>
+            <a:pPr algn="l">
+              <a:lnSpc>
+                <a:spcPct val="115000"/>
+              </a:lnSpc>
+              <a:spcBef>
+                <a:spcPts val="300"/>
+              </a:spcBef>
+            </a:pPr>
+            <a:r>
+              <a:rPr sz="1200" b="0">
+                <a:solidFill>
+                  <a:srgbClr val="52514E"/>
+                </a:solidFill>
+                <a:latin typeface="Inter"/>
+              </a:rPr>
+              <a:t>ω rescaling</a:t>
             </a:r>
           </a:p>
           <a:p>
@@ -10775,7 +10794,7 @@
                 </a:solidFill>
                 <a:latin typeface="Inter"/>
               </a:rPr>
-              <a:t>ω slider (exact rescaling)</a:t>
+              <a:t>ω slider (exact scaling law)</a:t>
             </a:r>
           </a:p>
           <a:p>
@@ -11145,7 +11164,7 @@
                 </a:solidFill>
                 <a:latin typeface="Inter"/>
               </a:rPr>
-              <a:t>Finite differences reproduce E_n = n + ½ to 8e-04 with 2401 points in ~16 ms</a:t>
+              <a:t>Finite differences reproduce E_n = n + ½ to 8e-04 with 2401 points in ~21 ms</a:t>
             </a:r>
           </a:p>
           <a:p>
@@ -11448,7 +11467,7 @@
                 </a:solidFill>
                 <a:latin typeface="Inter"/>
               </a:rPr>
-              <a:t>The ω slider rescales the ω = 1 solution. This is exact for this potential, but it is not a re-solve</a:t>
+              <a:t>The ω slider rescales the ω = 1 result. This is identical to re-solving on a grid scaled by 1/√ω (tested)</a:t>
             </a:r>
           </a:p>
         </p:txBody>

</xml_diff>